<commit_message>
Update Vestal Pro readout deck
Co-Authored-By: Claude Fable 5 <noreply@anthropic.com>
Claude-Session: https://claude.ai/code/session_016HQksKQCeopnDvdiMbgyZq
</commit_message>
<xml_diff>
--- a/deliverables/VestalPro_Campaign_Readout_iter2.pptx
+++ b/deliverables/VestalPro_Campaign_Readout_iter2.pptx
@@ -277,7 +277,7 @@
       </p15:sldGuideLst>
     </p:ext>
     <p:ext uri="GoogleSlidesCustomDataVersion2">
-      <go:slidesCustomData xmlns="" xmlns:mc="http://schemas.openxmlformats.org/markup-compatibility/2006" xmlns:mv="urn:schemas-microsoft-com:mac:vml" xmlns:c="http://schemas.openxmlformats.org/drawingml/2006/chart" xmlns:dgm="http://schemas.openxmlformats.org/drawingml/2006/diagram" xmlns:o="urn:schemas-microsoft-com:office:office" xmlns:v="urn:schemas-microsoft-com:vml" xmlns:pvml="urn:schemas-microsoft-com:office:powerpoint" xmlns:com="http://schemas.openxmlformats.org/drawingml/2006/compatibility" xmlns:p14="http://schemas.microsoft.com/office/powerpoint/2010/main" xmlns:p15="http://schemas.microsoft.com/office/powerpoint/2012/main" xmlns:ahyp="http://schemas.microsoft.com/office/drawing/2018/hyperlinkcolor" xmlns:go="http://customooxmlschemas.google.com/" r:id="rId24" roundtripDataSignature="AMtx7mjYpyT7O49FwNOEKdjeHwjl0PwSDg=="/>
+      <go:slidesCustomData xmlns:go="http://customooxmlschemas.google.com/" xmlns:ahyp="http://schemas.microsoft.com/office/drawing/2018/hyperlinkcolor" xmlns:p15="http://schemas.microsoft.com/office/powerpoint/2012/main" xmlns:p14="http://schemas.microsoft.com/office/powerpoint/2010/main" xmlns:com="http://schemas.openxmlformats.org/drawingml/2006/compatibility" xmlns:pvml="urn:schemas-microsoft-com:office:powerpoint" xmlns:v="urn:schemas-microsoft-com:vml" xmlns:o="urn:schemas-microsoft-com:office:office" xmlns:dgm="http://schemas.openxmlformats.org/drawingml/2006/diagram" xmlns:c="http://schemas.openxmlformats.org/drawingml/2006/chart" xmlns:mv="urn:schemas-microsoft-com:mac:vml" xmlns:mc="http://schemas.openxmlformats.org/markup-compatibility/2006" xmlns="" r:id="rId24" roundtripDataSignature="AMtx7mjYpyT7O49FwNOEKdjeHwjl0PwSDg=="/>
     </p:ext>
   </p:extLst>
 </p:presentation>
@@ -26036,7 +26036,7 @@
                 <a:sym typeface="Arial"/>
                 <a:extLst>
                   <a:ext uri="http://customooxmlschemas.google.com/">
-                    <go:slidesCustomData xmlns="" xmlns:mc="http://schemas.openxmlformats.org/markup-compatibility/2006" xmlns:mv="urn:schemas-microsoft-com:mac:vml" xmlns:c="http://schemas.openxmlformats.org/drawingml/2006/chart" xmlns:dgm="http://schemas.openxmlformats.org/drawingml/2006/diagram" xmlns:o="urn:schemas-microsoft-com:office:office" xmlns:v="urn:schemas-microsoft-com:vml" xmlns:pvml="urn:schemas-microsoft-com:office:powerpoint" xmlns:com="http://schemas.openxmlformats.org/drawingml/2006/compatibility" xmlns:p14="http://schemas.microsoft.com/office/powerpoint/2010/main" xmlns:p15="http://schemas.microsoft.com/office/powerpoint/2012/main" xmlns:ahyp="http://schemas.microsoft.com/office/drawing/2018/hyperlinkcolor" xmlns:go="http://customooxmlschemas.google.com/" textRoundtripDataId="0"/>
+                    <go:slidesCustomData xmlns:go="http://customooxmlschemas.google.com/" xmlns:ahyp="http://schemas.microsoft.com/office/drawing/2018/hyperlinkcolor" xmlns:p15="http://schemas.microsoft.com/office/powerpoint/2012/main" xmlns:p14="http://schemas.microsoft.com/office/powerpoint/2010/main" xmlns:com="http://schemas.openxmlformats.org/drawingml/2006/compatibility" xmlns:pvml="urn:schemas-microsoft-com:office:powerpoint" xmlns:v="urn:schemas-microsoft-com:vml" xmlns:o="urn:schemas-microsoft-com:office:office" xmlns:dgm="http://schemas.openxmlformats.org/drawingml/2006/diagram" xmlns:c="http://schemas.openxmlformats.org/drawingml/2006/chart" xmlns:mv="urn:schemas-microsoft-com:mac:vml" xmlns:mc="http://schemas.openxmlformats.org/markup-compatibility/2006" xmlns="" textRoundtripDataId="0"/>
                   </a:ext>
                 </a:extLst>
               </a:rPr>
@@ -26193,7 +26193,7 @@
               <a:buNone/>
             </a:pPr>
             <a:r>
-              <a:rPr lang="en-US" sz="1000" b="1" i="0" u="none" strike="noStrike" cap="none">
+              <a:rPr lang="en-US" sz="1000" b="1" i="0" u="none" strike="noStrike" cap="none" dirty="0">
                 <a:solidFill>
                   <a:srgbClr val="757575"/>
                 </a:solidFill>
@@ -26204,7 +26204,7 @@
               </a:rPr>
               <a:t>INCREMENTAL FOOTWEAR REVENUE</a:t>
             </a:r>
-            <a:endParaRPr/>
+            <a:endParaRPr dirty="0"/>
           </a:p>
         </p:txBody>
       </p:sp>
@@ -26346,7 +26346,7 @@
               <a:buNone/>
             </a:pPr>
             <a:r>
-              <a:rPr lang="en-US" sz="1050" b="0" i="0" u="none" strike="noStrike" cap="none">
+              <a:rPr lang="en-US" sz="1050" b="0" i="0" u="none" strike="noStrike" cap="none" dirty="0">
                 <a:solidFill>
                   <a:srgbClr val="757575"/>
                 </a:solidFill>
@@ -26358,7 +26358,7 @@
               <a:t>Target ≥ +10%  ·  </a:t>
             </a:r>
             <a:r>
-              <a:rPr lang="en-US" sz="1050" b="1" i="0" u="none" strike="noStrike" cap="none">
+              <a:rPr lang="en-US" sz="1050" b="1" i="0" u="none" strike="noStrike" cap="none" dirty="0">
                 <a:solidFill>
                   <a:srgbClr val="1F7A4D"/>
                 </a:solidFill>
@@ -26369,7 +26369,7 @@
               </a:rPr>
               <a:t>PASS</a:t>
             </a:r>
-            <a:endParaRPr/>
+            <a:endParaRPr dirty="0"/>
           </a:p>
         </p:txBody>
       </p:sp>

</xml_diff>

<commit_message>
Reorder exec summary KPI boxes and add pass/fail badges
Cannibalization box now moves last (red/FAIL), green boxes lead
(revenue, new-customer share, halo). Adds the $30.5K displaced-
revenue estimate to the cannibalization box subtext.

Co-Authored-By: Claude Fable 5 <noreply@anthropic.com>
Claude-Session: https://claude.ai/code/session_016HQksKQCeopnDvdiMbgyZq
</commit_message>
<xml_diff>
--- a/deliverables/VestalPro_Campaign_Readout_iter2.pptx
+++ b/deliverables/VestalPro_Campaign_Readout_iter2.pptx
@@ -277,7 +277,7 @@
       </p15:sldGuideLst>
     </p:ext>
     <p:ext uri="GoogleSlidesCustomDataVersion2">
-      <go:slidesCustomData xmlns:go="http://customooxmlschemas.google.com/" xmlns:ahyp="http://schemas.microsoft.com/office/drawing/2018/hyperlinkcolor" xmlns:p15="http://schemas.microsoft.com/office/powerpoint/2012/main" xmlns:p14="http://schemas.microsoft.com/office/powerpoint/2010/main" xmlns:com="http://schemas.openxmlformats.org/drawingml/2006/compatibility" xmlns:pvml="urn:schemas-microsoft-com:office:powerpoint" xmlns:v="urn:schemas-microsoft-com:vml" xmlns:o="urn:schemas-microsoft-com:office:office" xmlns:dgm="http://schemas.openxmlformats.org/drawingml/2006/diagram" xmlns:c="http://schemas.openxmlformats.org/drawingml/2006/chart" xmlns:mv="urn:schemas-microsoft-com:mac:vml" xmlns:mc="http://schemas.openxmlformats.org/markup-compatibility/2006" xmlns="" r:id="rId24" roundtripDataSignature="AMtx7mjYpyT7O49FwNOEKdjeHwjl0PwSDg=="/>
+      <go:slidesCustomData xmlns="" xmlns:mc="http://schemas.openxmlformats.org/markup-compatibility/2006" xmlns:mv="urn:schemas-microsoft-com:mac:vml" xmlns:c="http://schemas.openxmlformats.org/drawingml/2006/chart" xmlns:dgm="http://schemas.openxmlformats.org/drawingml/2006/diagram" xmlns:o="urn:schemas-microsoft-com:office:office" xmlns:v="urn:schemas-microsoft-com:vml" xmlns:pvml="urn:schemas-microsoft-com:office:powerpoint" xmlns:com="http://schemas.openxmlformats.org/drawingml/2006/compatibility" xmlns:p14="http://schemas.microsoft.com/office/powerpoint/2010/main" xmlns:p15="http://schemas.microsoft.com/office/powerpoint/2012/main" xmlns:ahyp="http://schemas.microsoft.com/office/drawing/2018/hyperlinkcolor" xmlns:go="http://customooxmlschemas.google.com/" r:id="rId24" roundtripDataSignature="AMtx7mjYpyT7O49FwNOEKdjeHwjl0PwSDg=="/>
     </p:ext>
   </p:extLst>
 </p:presentation>
@@ -26036,7 +26036,7 @@
                 <a:sym typeface="Arial"/>
                 <a:extLst>
                   <a:ext uri="http://customooxmlschemas.google.com/">
-                    <go:slidesCustomData xmlns:go="http://customooxmlschemas.google.com/" xmlns:ahyp="http://schemas.microsoft.com/office/drawing/2018/hyperlinkcolor" xmlns:p15="http://schemas.microsoft.com/office/powerpoint/2012/main" xmlns:p14="http://schemas.microsoft.com/office/powerpoint/2010/main" xmlns:com="http://schemas.openxmlformats.org/drawingml/2006/compatibility" xmlns:pvml="urn:schemas-microsoft-com:office:powerpoint" xmlns:v="urn:schemas-microsoft-com:vml" xmlns:o="urn:schemas-microsoft-com:office:office" xmlns:dgm="http://schemas.openxmlformats.org/drawingml/2006/diagram" xmlns:c="http://schemas.openxmlformats.org/drawingml/2006/chart" xmlns:mv="urn:schemas-microsoft-com:mac:vml" xmlns:mc="http://schemas.openxmlformats.org/markup-compatibility/2006" xmlns="" textRoundtripDataId="0"/>
+                    <go:slidesCustomData xmlns="" xmlns:mc="http://schemas.openxmlformats.org/markup-compatibility/2006" xmlns:mv="urn:schemas-microsoft-com:mac:vml" xmlns:c="http://schemas.openxmlformats.org/drawingml/2006/chart" xmlns:dgm="http://schemas.openxmlformats.org/drawingml/2006/diagram" xmlns:o="urn:schemas-microsoft-com:office:office" xmlns:v="urn:schemas-microsoft-com:vml" xmlns:pvml="urn:schemas-microsoft-com:office:powerpoint" xmlns:com="http://schemas.openxmlformats.org/drawingml/2006/compatibility" xmlns:p14="http://schemas.microsoft.com/office/powerpoint/2010/main" xmlns:p15="http://schemas.microsoft.com/office/powerpoint/2012/main" xmlns:ahyp="http://schemas.microsoft.com/office/drawing/2018/hyperlinkcolor" xmlns:go="http://customooxmlschemas.google.com/" textRoundtripDataId="0"/>
                   </a:ext>
                 </a:extLst>
               </a:rPr>
@@ -26650,7 +26650,7 @@
         </p:nvSpPr>
         <p:spPr>
           <a:xfrm>
-            <a:off x="6190488" y="1481328"/>
+            <a:off x="9034272" y="1481328"/>
             <a:ext cx="2706624" cy="2606040"/>
           </a:xfrm>
           <a:prstGeom prst="rect">
@@ -26704,7 +26704,7 @@
         </p:nvSpPr>
         <p:spPr>
           <a:xfrm>
-            <a:off x="6391655" y="1700784"/>
+            <a:off x="9235440" y="1700784"/>
             <a:ext cx="2331720" cy="594360"/>
           </a:xfrm>
           <a:prstGeom prst="rect">
@@ -26754,7 +26754,7 @@
         </p:nvSpPr>
         <p:spPr>
           <a:xfrm>
-            <a:off x="6391655" y="2286000"/>
+            <a:off x="9235440" y="2286000"/>
             <a:ext cx="2331720" cy="777240"/>
           </a:xfrm>
           <a:prstGeom prst="rect">
@@ -26804,8 +26804,8 @@
         </p:nvSpPr>
         <p:spPr>
           <a:xfrm>
-            <a:off x="6391655" y="3127248"/>
-            <a:ext cx="2331720" cy="548640"/>
+            <a:off x="9235440" y="3127248"/>
+            <a:ext cx="2331720" cy="339324"/>
           </a:xfrm>
           <a:prstGeom prst="rect">
             <a:avLst/>
@@ -26834,7 +26834,7 @@
               <a:buNone/>
             </a:pPr>
             <a:r>
-              <a:rPr lang="en-US" sz="1050" b="0" i="0" u="none" strike="noStrike" cap="none">
+              <a:rPr lang="en-US" sz="1050" b="0" i="0" u="none" strike="noStrike" cap="none" dirty="0">
                 <a:solidFill>
                   <a:srgbClr val="333333"/>
                 </a:solidFill>
@@ -26843,9 +26843,9 @@
                 <a:cs typeface="Arial"/>
                 <a:sym typeface="Arial"/>
               </a:rPr>
-              <a:t>median 28% across three baseline models</a:t>
-            </a:r>
-            <a:endParaRPr/>
+              <a:t>−$30.5K existing-shoe revenue displaced</a:t>
+            </a:r>
+            <a:endParaRPr dirty="0"/>
           </a:p>
         </p:txBody>
       </p:sp>
@@ -26857,7 +26857,7 @@
         </p:nvSpPr>
         <p:spPr>
           <a:xfrm>
-            <a:off x="6391655" y="3712463"/>
+            <a:off x="9235440" y="3712463"/>
             <a:ext cx="2331720" cy="161583"/>
           </a:xfrm>
           <a:prstGeom prst="rect">
@@ -26884,7 +26884,7 @@
               <a:buNone/>
             </a:pPr>
             <a:r>
-              <a:rPr lang="en-US" sz="1050" b="0" i="0" u="none" strike="noStrike" cap="none">
+              <a:rPr lang="en-US" sz="1050" b="0" i="0" u="none" strike="noStrike" cap="none" dirty="0">
                 <a:solidFill>
                   <a:srgbClr val="757575"/>
                 </a:solidFill>
@@ -26896,9 +26896,9 @@
               <a:t>Guardrail &lt; 10%  ·  </a:t>
             </a:r>
             <a:r>
-              <a:rPr lang="en-US" sz="1050" b="1" i="0" u="none" strike="noStrike" cap="none">
-                <a:solidFill>
-                  <a:srgbClr val="E36C09"/>
+              <a:rPr lang="en-US" sz="1050" b="1" i="0" u="none" strike="noStrike" cap="none" dirty="0">
+                <a:solidFill>
+                  <a:schemeClr val="accent1"/>
                 </a:solidFill>
                 <a:latin typeface="Arial"/>
                 <a:ea typeface="Arial"/>
@@ -26907,9 +26907,9 @@
               </a:rPr>
               <a:t>FLAG &amp; MONITOR</a:t>
             </a:r>
-            <a:endParaRPr sz="1050" b="1" i="0" u="none" strike="noStrike" cap="none">
+            <a:endParaRPr sz="1050" b="1" i="0" u="none" strike="noStrike" cap="none" dirty="0">
               <a:solidFill>
-                <a:srgbClr val="E36C09"/>
+                <a:schemeClr val="accent1"/>
               </a:solidFill>
               <a:latin typeface="Arial"/>
               <a:ea typeface="Arial"/>
@@ -26927,7 +26927,7 @@
         </p:nvSpPr>
         <p:spPr>
           <a:xfrm>
-            <a:off x="9034272" y="1481328"/>
+            <a:off x="6190488" y="1481328"/>
             <a:ext cx="2706624" cy="2606040"/>
           </a:xfrm>
           <a:prstGeom prst="rect">
@@ -26981,7 +26981,7 @@
         </p:nvSpPr>
         <p:spPr>
           <a:xfrm>
-            <a:off x="9235440" y="1700784"/>
+            <a:off x="6391655" y="1700784"/>
             <a:ext cx="2331720" cy="594360"/>
           </a:xfrm>
           <a:prstGeom prst="rect">
@@ -27031,7 +27031,7 @@
         </p:nvSpPr>
         <p:spPr>
           <a:xfrm>
-            <a:off x="9235440" y="2286000"/>
+            <a:off x="6391655" y="2286000"/>
             <a:ext cx="2331720" cy="777240"/>
           </a:xfrm>
           <a:prstGeom prst="rect">
@@ -27081,7 +27081,7 @@
         </p:nvSpPr>
         <p:spPr>
           <a:xfrm>
-            <a:off x="9235440" y="3127248"/>
+            <a:off x="6391655" y="3127248"/>
             <a:ext cx="2331720" cy="548640"/>
           </a:xfrm>
           <a:prstGeom prst="rect">
@@ -27134,7 +27134,7 @@
         </p:nvSpPr>
         <p:spPr>
           <a:xfrm>
-            <a:off x="9235440" y="3712463"/>
+            <a:off x="6391655" y="3712463"/>
             <a:ext cx="2331720" cy="274320"/>
           </a:xfrm>
           <a:prstGeom prst="rect">
@@ -27597,6 +27597,222 @@
           </a:ln>
         </p:spPr>
       </p:pic>
+      <p:sp>
+        <p:nvSpPr>
+          <p:cNvPr id="166" name="Google Shape;166;p3"/>
+          <p:cNvSpPr/>
+          <p:nvPr/>
+        </p:nvSpPr>
+        <p:spPr>
+          <a:xfrm>
+            <a:off x="1307592" y="1344168"/>
+            <a:ext cx="1097280" cy="274320"/>
+          </a:xfrm>
+          <a:prstGeom prst="roundRect">
+            <a:avLst>
+              <a:gd name="adj" fmla="val 50000"/>
+            </a:avLst>
+          </a:prstGeom>
+          <a:solidFill>
+            <a:srgbClr val="1F7A4D"/>
+          </a:solidFill>
+          <a:ln>
+            <a:noFill/>
+          </a:ln>
+        </p:spPr>
+        <p:txBody>
+          <a:bodyPr spcFirstLastPara="1" wrap="square" lIns="0" tIns="0" rIns="0" bIns="0" anchor="ctr" anchorCtr="0">
+            <a:noAutofit/>
+          </a:bodyPr>
+          <a:lstStyle/>
+          <a:p>
+            <a:pPr marL="0" marR="0" lvl="0" indent="0" algn="ctr" rtl="0">
+              <a:spcBef>
+                <a:spcPts val="0"/>
+              </a:spcBef>
+              <a:spcAft>
+                <a:spcPts val="0"/>
+              </a:spcAft>
+              <a:buNone/>
+            </a:pPr>
+            <a:r>
+              <a:rPr lang="en-US" sz="1100" b="1" i="0" u="none" strike="noStrike" cap="none">
+                <a:solidFill>
+                  <a:srgbClr val="FFFFFF"/>
+                </a:solidFill>
+                <a:latin typeface="Arial"/>
+                <a:ea typeface="Arial"/>
+                <a:cs typeface="Arial"/>
+                <a:sym typeface="Arial"/>
+              </a:rPr>
+              <a:t>PASS</a:t>
+            </a:r>
+            <a:endParaRPr/>
+          </a:p>
+        </p:txBody>
+      </p:sp>
+      <p:sp>
+        <p:nvSpPr>
+          <p:cNvPr id="167" name="Google Shape;167;p3"/>
+          <p:cNvSpPr/>
+          <p:nvPr/>
+        </p:nvSpPr>
+        <p:spPr>
+          <a:xfrm>
+            <a:off x="4151376" y="1344168"/>
+            <a:ext cx="1097280" cy="274320"/>
+          </a:xfrm>
+          <a:prstGeom prst="roundRect">
+            <a:avLst>
+              <a:gd name="adj" fmla="val 50000"/>
+            </a:avLst>
+          </a:prstGeom>
+          <a:solidFill>
+            <a:srgbClr val="1F7A4D"/>
+          </a:solidFill>
+          <a:ln>
+            <a:noFill/>
+          </a:ln>
+        </p:spPr>
+        <p:txBody>
+          <a:bodyPr spcFirstLastPara="1" wrap="square" lIns="0" tIns="0" rIns="0" bIns="0" anchor="ctr" anchorCtr="0">
+            <a:noAutofit/>
+          </a:bodyPr>
+          <a:lstStyle/>
+          <a:p>
+            <a:pPr marL="0" marR="0" lvl="0" indent="0" algn="ctr" rtl="0">
+              <a:spcBef>
+                <a:spcPts val="0"/>
+              </a:spcBef>
+              <a:spcAft>
+                <a:spcPts val="0"/>
+              </a:spcAft>
+              <a:buNone/>
+            </a:pPr>
+            <a:r>
+              <a:rPr lang="en-US" sz="1100" b="1" i="0" u="none" strike="noStrike" cap="none">
+                <a:solidFill>
+                  <a:srgbClr val="FFFFFF"/>
+                </a:solidFill>
+                <a:latin typeface="Arial"/>
+                <a:ea typeface="Arial"/>
+                <a:cs typeface="Arial"/>
+                <a:sym typeface="Arial"/>
+              </a:rPr>
+              <a:t>PASS</a:t>
+            </a:r>
+            <a:endParaRPr/>
+          </a:p>
+        </p:txBody>
+      </p:sp>
+      <p:sp>
+        <p:nvSpPr>
+          <p:cNvPr id="168" name="Google Shape;168;p3"/>
+          <p:cNvSpPr/>
+          <p:nvPr/>
+        </p:nvSpPr>
+        <p:spPr>
+          <a:xfrm>
+            <a:off x="6995160" y="1344168"/>
+            <a:ext cx="1097280" cy="274320"/>
+          </a:xfrm>
+          <a:prstGeom prst="roundRect">
+            <a:avLst>
+              <a:gd name="adj" fmla="val 50000"/>
+            </a:avLst>
+          </a:prstGeom>
+          <a:solidFill>
+            <a:srgbClr val="1F7A4D"/>
+          </a:solidFill>
+          <a:ln>
+            <a:noFill/>
+          </a:ln>
+        </p:spPr>
+        <p:txBody>
+          <a:bodyPr spcFirstLastPara="1" wrap="square" lIns="0" tIns="0" rIns="0" bIns="0" anchor="ctr" anchorCtr="0">
+            <a:noAutofit/>
+          </a:bodyPr>
+          <a:lstStyle/>
+          <a:p>
+            <a:pPr marL="0" marR="0" lvl="0" indent="0" algn="ctr" rtl="0">
+              <a:spcBef>
+                <a:spcPts val="0"/>
+              </a:spcBef>
+              <a:spcAft>
+                <a:spcPts val="0"/>
+              </a:spcAft>
+              <a:buNone/>
+            </a:pPr>
+            <a:r>
+              <a:rPr lang="en-US" sz="1100" b="1" i="0" u="none" strike="noStrike" cap="none">
+                <a:solidFill>
+                  <a:srgbClr val="FFFFFF"/>
+                </a:solidFill>
+                <a:latin typeface="Arial"/>
+                <a:ea typeface="Arial"/>
+                <a:cs typeface="Arial"/>
+                <a:sym typeface="Arial"/>
+              </a:rPr>
+              <a:t>PASS</a:t>
+            </a:r>
+            <a:endParaRPr/>
+          </a:p>
+        </p:txBody>
+      </p:sp>
+      <p:sp>
+        <p:nvSpPr>
+          <p:cNvPr id="169" name="Google Shape;169;p3"/>
+          <p:cNvSpPr/>
+          <p:nvPr/>
+        </p:nvSpPr>
+        <p:spPr>
+          <a:xfrm>
+            <a:off x="9838944" y="1344168"/>
+            <a:ext cx="1097280" cy="274320"/>
+          </a:xfrm>
+          <a:prstGeom prst="roundRect">
+            <a:avLst>
+              <a:gd name="adj" fmla="val 50000"/>
+            </a:avLst>
+          </a:prstGeom>
+          <a:solidFill>
+            <a:srgbClr val="DA291C"/>
+          </a:solidFill>
+          <a:ln>
+            <a:noFill/>
+          </a:ln>
+        </p:spPr>
+        <p:txBody>
+          <a:bodyPr spcFirstLastPara="1" wrap="square" lIns="0" tIns="0" rIns="0" bIns="0" anchor="ctr" anchorCtr="0">
+            <a:noAutofit/>
+          </a:bodyPr>
+          <a:lstStyle/>
+          <a:p>
+            <a:pPr marL="0" marR="0" lvl="0" indent="0" algn="ctr" rtl="0">
+              <a:spcBef>
+                <a:spcPts val="0"/>
+              </a:spcBef>
+              <a:spcAft>
+                <a:spcPts val="0"/>
+              </a:spcAft>
+              <a:buNone/>
+            </a:pPr>
+            <a:r>
+              <a:rPr lang="en-US" sz="1100" b="1" i="0" u="none" strike="noStrike" cap="none">
+                <a:solidFill>
+                  <a:srgbClr val="FFFFFF"/>
+                </a:solidFill>
+                <a:latin typeface="Arial"/>
+                <a:ea typeface="Arial"/>
+                <a:cs typeface="Arial"/>
+                <a:sym typeface="Arial"/>
+              </a:rPr>
+              <a:t>FAIL</a:t>
+            </a:r>
+            <a:endParaRPr/>
+          </a:p>
+        </p:txBody>
+      </p:sp>
     </p:spTree>
   </p:cSld>
   <p:clrMapOvr>

</xml_diff>

<commit_message>
Add appendix deep-dive slides and finalize Vestal Pro readout
- iter3 deck: 9 appendix slides (baseline validation, cannibalization
  detail, channel economics, LTV, inventory, returns, incrementality
  reconciliation, brand-search persistence, assumptions register as a
  native table)
- src/make_appendix_charts.py reproduces all appendix charts
  (--no-subtitle/--outdir flags); plots/appendix_* and no-subheader set
- Chart wording: "franchise" -> "shoe"/"product line"
- Notebook: first-person voice pass; cannibalization guardrail 10%
- README cannibalization criterion 10%; channel table adds new-customer
  count and CAC
- gitignore PowerPoint lock files and Zone.Identifier streams

Co-Authored-By: Claude Fable 5 <noreply@anthropic.com>
Claude-Session: https://claude.ai/code/session_016HQksKQCeopnDvdiMbgyZq
</commit_message>
<xml_diff>
--- a/deliverables/VestalPro_Campaign_Readout_iter2.pptx
+++ b/deliverables/VestalPro_Campaign_Readout_iter2.pptx
@@ -900,34 +900,6 @@
 </pc:chgInfo>
 </file>
 
-<file path=ppt/comments/modernComment_103_0.xml><?xml version="1.0" encoding="utf-8"?>
-<p188:cmLst xmlns:a="http://schemas.openxmlformats.org/drawingml/2006/main" xmlns:r="http://schemas.openxmlformats.org/officeDocument/2006/relationships" xmlns:p188="http://schemas.microsoft.com/office/powerpoint/2018/8/main">
-  <p188:cm id="{D4C3210B-4185-49E8-B774-0BAB29307DDB}" authorId="{F7CB7528-0317-1151-A7B7-34D5B6A94F6F}" created="2026-07-19T23:07:19.254">
-    <ac:txMkLst xmlns:ac="http://schemas.microsoft.com/office/drawing/2013/main/command">
-      <pc:docMk xmlns:pc="http://schemas.microsoft.com/office/powerpoint/2013/main/command"/>
-      <pc:sldMk xmlns:pc="http://schemas.microsoft.com/office/powerpoint/2013/main/command" cId="0" sldId="259"/>
-      <ac:graphicFrameMk id="400" creationId="{00000000-0000-0000-0000-000000000000}"/>
-      <ac:tblMk/>
-      <ac:tcMk rowId="10003" colId="20002"/>
-      <ac:txMk cp="0" len="45">
-        <ac:context len="46" hash="1022678855"/>
-      </ac:txMk>
-    </ac:txMkLst>
-    <p188:pos x="8641080" y="1152964"/>
-    <p188:txBody>
-      <a:bodyPr/>
-      <a:lstStyle/>
-      <a:p>
-        <a:r>
-          <a:rPr lang="en-US"/>
-          <a:t>Remove the 3rd row? </a:t>
-        </a:r>
-      </a:p>
-    </p188:txBody>
-  </p188:cm>
-</p188:cmLst>
-</file>
-
 <file path=ppt/notesMasters/notesMaster1.xml><?xml version="1.0" encoding="utf-8"?>
 <p:notesMaster xmlns:a="http://schemas.openxmlformats.org/drawingml/2006/main" xmlns:r="http://schemas.openxmlformats.org/officeDocument/2006/relationships" xmlns:p="http://schemas.openxmlformats.org/presentationml/2006/main">
   <p:cSld>
@@ -4078,7 +4050,43 @@
               </a:spcAft>
               <a:buNone/>
             </a:pPr>
-            <a:endParaRPr/>
+            <a:r>
+              <a:rPr lang="en-US" sz="1200" b="0" i="0" dirty="0">
+                <a:solidFill>
+                  <a:srgbClr val="333333"/>
+                </a:solidFill>
+                <a:latin typeface="Arial"/>
+                <a:ea typeface="Arial"/>
+                <a:cs typeface="Arial"/>
+                <a:sym typeface="Arial"/>
+              </a:rPr>
+              <a:t>95% CI +32% to +</a:t>
+            </a:r>
+            <a:r>
+              <a:rPr lang="en-US" sz="1200" dirty="0">
+                <a:solidFill>
+                  <a:srgbClr val="333333"/>
+                </a:solidFill>
+                <a:latin typeface="Arial"/>
+                <a:ea typeface="Arial"/>
+                <a:cs typeface="Arial"/>
+                <a:sym typeface="Arial"/>
+              </a:rPr>
+              <a:t>40</a:t>
+            </a:r>
+            <a:r>
+              <a:rPr lang="en-US" sz="1200" b="0" i="0" dirty="0">
+                <a:solidFill>
+                  <a:srgbClr val="333333"/>
+                </a:solidFill>
+                <a:latin typeface="Arial"/>
+                <a:ea typeface="Arial"/>
+                <a:cs typeface="Arial"/>
+                <a:sym typeface="Arial"/>
+              </a:rPr>
+              <a:t>% above baseline</a:t>
+            </a:r>
+            <a:endParaRPr dirty="0"/>
           </a:p>
         </p:txBody>
       </p:sp>
@@ -15102,8 +15110,8 @@
         </p:nvSpPr>
         <p:spPr>
           <a:xfrm flipV="1">
-            <a:off x="7767023" y="1834764"/>
-            <a:ext cx="3782340" cy="2951677"/>
+            <a:off x="7712490" y="1834764"/>
+            <a:ext cx="3946109" cy="2844962"/>
           </a:xfrm>
           <a:prstGeom prst="roundRect">
             <a:avLst>
@@ -15121,7 +15129,7 @@
           <a:bodyPr/>
           <a:lstStyle/>
           <a:p>
-            <a:endParaRPr/>
+            <a:endParaRPr dirty="0"/>
           </a:p>
         </p:txBody>
       </p:sp>
@@ -15218,7 +15226,7 @@
               <a:buNone/>
             </a:pPr>
             <a:r>
-              <a:rPr lang="en-US" sz="2300" b="0" i="0">
+              <a:rPr lang="en-US" sz="2300" b="0" i="0" dirty="0">
                 <a:solidFill>
                   <a:srgbClr val="000000"/>
                 </a:solidFill>
@@ -15227,9 +15235,9 @@
                 <a:cs typeface="Georgia"/>
                 <a:sym typeface="Georgia"/>
               </a:rPr>
-              <a:t>Projected 24-month value of ~$387 per new customer; 3.8× acquisition cost</a:t>
-            </a:r>
-            <a:endParaRPr sz="2300" b="0" i="0">
+              <a:t>Projected 24-month value of $387 per new customer; 3.8× acquisition cost</a:t>
+            </a:r>
+            <a:endParaRPr sz="2300" b="0" i="0" dirty="0">
               <a:solidFill>
                 <a:srgbClr val="000000"/>
               </a:solidFill>
@@ -15515,7 +15523,10 @@
             <a:r>
               <a:rPr lang="en-US" sz="1200" dirty="0">
                 <a:solidFill>
-                  <a:srgbClr val="3F3F3F"/>
+                  <a:schemeClr val="bg2">
+                    <a:lumMod val="65000"/>
+                    <a:lumOff val="35000"/>
+                  </a:schemeClr>
                 </a:solidFill>
                 <a:latin typeface="Arial"/>
                 <a:ea typeface="Arial"/>
@@ -15527,7 +15538,10 @@
             <a:r>
               <a:rPr lang="en-US" sz="1200" b="1" dirty="0">
                 <a:solidFill>
-                  <a:srgbClr val="3F3F3F"/>
+                  <a:schemeClr val="bg2">
+                    <a:lumMod val="65000"/>
+                    <a:lumOff val="35000"/>
+                  </a:schemeClr>
                 </a:solidFill>
                 <a:latin typeface="Arial"/>
                 <a:ea typeface="Arial"/>
@@ -15539,7 +15553,10 @@
             <a:r>
               <a:rPr lang="en-US" sz="1200" dirty="0">
                 <a:solidFill>
-                  <a:srgbClr val="3F3F3F"/>
+                  <a:schemeClr val="bg2">
+                    <a:lumMod val="65000"/>
+                    <a:lumOff val="35000"/>
+                  </a:schemeClr>
                 </a:solidFill>
                 <a:latin typeface="Arial"/>
                 <a:ea typeface="Arial"/>
@@ -15548,7 +15565,14 @@
               </a:rPr>
               <a:t>at 24 months (3.8x CAC) based on prior CLV cohort analysis.</a:t>
             </a:r>
-            <a:endParaRPr dirty="0"/>
+            <a:endParaRPr dirty="0">
+              <a:solidFill>
+                <a:schemeClr val="bg2">
+                  <a:lumMod val="65000"/>
+                  <a:lumOff val="35000"/>
+                </a:schemeClr>
+              </a:solidFill>
+            </a:endParaRPr>
           </a:p>
           <a:p>
             <a:pPr marL="0" marR="0" lvl="0" indent="0" algn="l" rtl="0">
@@ -15562,7 +15586,10 @@
             </a:pPr>
             <a:endParaRPr sz="1200" dirty="0">
               <a:solidFill>
-                <a:srgbClr val="3F3F3F"/>
+                <a:schemeClr val="bg2">
+                  <a:lumMod val="65000"/>
+                  <a:lumOff val="35000"/>
+                </a:schemeClr>
               </a:solidFill>
               <a:latin typeface="Arial"/>
               <a:ea typeface="Arial"/>
@@ -15583,7 +15610,10 @@
             <a:r>
               <a:rPr lang="en-US" sz="1200" dirty="0">
                 <a:solidFill>
-                  <a:srgbClr val="3F3F3F"/>
+                  <a:schemeClr val="bg2">
+                    <a:lumMod val="65000"/>
+                    <a:lumOff val="35000"/>
+                  </a:schemeClr>
                 </a:solidFill>
                 <a:latin typeface="Arial"/>
                 <a:ea typeface="Arial"/>
@@ -15595,7 +15625,10 @@
             <a:r>
               <a:rPr lang="en-US" sz="1200" b="1" dirty="0">
                 <a:solidFill>
-                  <a:srgbClr val="3F3F3F"/>
+                  <a:schemeClr val="bg2">
+                    <a:lumMod val="65000"/>
+                    <a:lumOff val="35000"/>
+                  </a:schemeClr>
                 </a:solidFill>
                 <a:latin typeface="Arial"/>
                 <a:ea typeface="Arial"/>
@@ -15607,7 +15640,10 @@
             <a:r>
               <a:rPr lang="en-US" sz="1200" dirty="0">
                 <a:solidFill>
-                  <a:srgbClr val="3F3F3F"/>
+                  <a:schemeClr val="bg2">
+                    <a:lumMod val="65000"/>
+                    <a:lumOff val="35000"/>
+                  </a:schemeClr>
                 </a:solidFill>
                 <a:latin typeface="Arial"/>
                 <a:ea typeface="Arial"/>
@@ -15616,7 +15652,14 @@
               </a:rPr>
               <a:t>We will see most of the LTV within the first 12 months (Roughly 86% accrues within the first year).</a:t>
             </a:r>
-            <a:endParaRPr dirty="0"/>
+            <a:endParaRPr dirty="0">
+              <a:solidFill>
+                <a:schemeClr val="bg2">
+                  <a:lumMod val="65000"/>
+                  <a:lumOff val="35000"/>
+                </a:schemeClr>
+              </a:solidFill>
+            </a:endParaRPr>
           </a:p>
           <a:p>
             <a:pPr marL="0" marR="0" lvl="0" indent="0" algn="l" rtl="0">
@@ -15630,7 +15673,10 @@
             </a:pPr>
             <a:endParaRPr sz="1200" dirty="0">
               <a:solidFill>
-                <a:srgbClr val="3F3F3F"/>
+                <a:schemeClr val="bg2">
+                  <a:lumMod val="65000"/>
+                  <a:lumOff val="35000"/>
+                </a:schemeClr>
               </a:solidFill>
               <a:latin typeface="Arial"/>
               <a:ea typeface="Arial"/>
@@ -15651,7 +15697,10 @@
             <a:r>
               <a:rPr lang="en-US" sz="1200" dirty="0">
                 <a:solidFill>
-                  <a:srgbClr val="3F3F3F"/>
+                  <a:schemeClr val="bg2">
+                    <a:lumMod val="65000"/>
+                    <a:lumOff val="35000"/>
+                  </a:schemeClr>
                 </a:solidFill>
                 <a:latin typeface="Arial"/>
                 <a:ea typeface="Arial"/>
@@ -15663,7 +15712,10 @@
             <a:r>
               <a:rPr lang="en-US" sz="1200" b="1" dirty="0">
                 <a:solidFill>
-                  <a:srgbClr val="3F3F3F"/>
+                  <a:schemeClr val="bg2">
+                    <a:lumMod val="65000"/>
+                    <a:lumOff val="35000"/>
+                  </a:schemeClr>
                 </a:solidFill>
                 <a:latin typeface="Arial"/>
                 <a:ea typeface="Arial"/>
@@ -15675,7 +15727,10 @@
             <a:r>
               <a:rPr lang="en-US" sz="1200" dirty="0">
                 <a:solidFill>
-                  <a:srgbClr val="3F3F3F"/>
+                  <a:schemeClr val="bg2">
+                    <a:lumMod val="65000"/>
+                    <a:lumOff val="35000"/>
+                  </a:schemeClr>
                 </a:solidFill>
                 <a:latin typeface="Arial"/>
                 <a:ea typeface="Arial"/>
@@ -15686,7 +15741,10 @@
             </a:r>
             <a:endParaRPr sz="1200" dirty="0">
               <a:solidFill>
-                <a:schemeClr val="dk1"/>
+                <a:schemeClr val="bg2">
+                  <a:lumMod val="65000"/>
+                  <a:lumOff val="35000"/>
+                </a:schemeClr>
               </a:solidFill>
               <a:latin typeface="Arial"/>
               <a:ea typeface="Arial"/>
@@ -15891,7 +15949,7 @@
               <a:buNone/>
             </a:pPr>
             <a:r>
-              <a:rPr lang="en-US" sz="2300" b="0" i="0">
+              <a:rPr lang="en-US" sz="2300" b="0" i="0" dirty="0">
                 <a:solidFill>
                   <a:srgbClr val="000000"/>
                 </a:solidFill>
@@ -15900,9 +15958,9 @@
                 <a:cs typeface="Georgia"/>
                 <a:sym typeface="Georgia"/>
               </a:rPr>
-              <a:t>All channels cleared breakeven except for paid social</a:t>
-            </a:r>
-            <a:endParaRPr sz="2300" b="0" i="0">
+              <a:t>All channels cleared breakeven except paid social; Paid is highest acquisition source</a:t>
+            </a:r>
+            <a:endParaRPr sz="2300" b="0" i="0" dirty="0">
               <a:solidFill>
                 <a:srgbClr val="000000"/>
               </a:solidFill>
@@ -17331,7 +17389,7 @@
                     <a:p>
                       <a:pPr algn="r"/>
                       <a:r>
-                        <a:rPr lang="en-US" sz="1000" b="0">
+                        <a:rPr lang="en-US" sz="1000" b="0" dirty="0">
                           <a:solidFill>
                             <a:srgbClr val="333333"/>
                           </a:solidFill>
@@ -19625,7 +19683,7 @@
               <a:buNone/>
             </a:pPr>
             <a:r>
-              <a:rPr lang="en-US" sz="2300" b="0" i="0">
+              <a:rPr lang="en-US" sz="2300" b="0" i="0" dirty="0">
                 <a:solidFill>
                   <a:srgbClr val="000000"/>
                 </a:solidFill>
@@ -19637,7 +19695,7 @@
               <a:t>Campaign investment supports persisten</a:t>
             </a:r>
             <a:r>
-              <a:rPr lang="en-US" sz="2300">
+              <a:rPr lang="en-US" sz="2300" dirty="0">
                 <a:solidFill>
                   <a:srgbClr val="000000"/>
                 </a:solidFill>
@@ -19648,7 +19706,7 @@
               </a:rPr>
               <a:t>t brand awareness and recognition</a:t>
             </a:r>
-            <a:endParaRPr sz="2300" b="0" i="0">
+            <a:endParaRPr sz="2300" b="0" i="0" dirty="0">
               <a:solidFill>
                 <a:srgbClr val="000000"/>
               </a:solidFill>
@@ -20677,7 +20735,7 @@
               <a:buNone/>
             </a:pPr>
             <a:r>
-              <a:rPr lang="en-US" sz="2300" b="0" i="0">
+              <a:rPr lang="en-US" sz="2300" b="0" i="0" dirty="0">
                 <a:solidFill>
                   <a:srgbClr val="000000"/>
                 </a:solidFill>
@@ -20688,7 +20746,7 @@
               </a:rPr>
               <a:t>Broken size curves from week 4 cost an estimated $16.2K in demand</a:t>
             </a:r>
-            <a:endParaRPr sz="2300" b="0" i="0">
+            <a:endParaRPr sz="2300" b="0" i="0" dirty="0">
               <a:solidFill>
                 <a:srgbClr val="000000"/>
               </a:solidFill>
@@ -21403,7 +21461,7 @@
               <a:buNone/>
             </a:pPr>
             <a:r>
-              <a:rPr lang="en-US" sz="1200" b="1">
+              <a:rPr lang="en-US" sz="1200" b="1" dirty="0">
                 <a:solidFill>
                   <a:srgbClr val="7F7F7F"/>
                 </a:solidFill>
@@ -21414,7 +21472,7 @@
               </a:rPr>
               <a:t>DEMAND OUTLIVED SUPPLY</a:t>
             </a:r>
-            <a:endParaRPr/>
+            <a:endParaRPr dirty="0"/>
           </a:p>
         </p:txBody>
       </p:sp>
@@ -21817,7 +21875,7 @@
                 <a:cs typeface="Arial"/>
                 <a:sym typeface="Arial"/>
               </a:rPr>
-              <a:t> and replenish. Increase WOS purchasing plan on core sizes and trigger replenishment when ATS breaks threshold.</a:t>
+              <a:t> and restock. Increase WOS purchasing plan on core sizes and trigger replenishment when ATS breaks threshold.</a:t>
             </a:r>
             <a:endParaRPr sz="1200" b="0" i="0" dirty="0">
               <a:solidFill>
@@ -23241,7 +23299,7 @@
                 <a:cs typeface="Arial"/>
                 <a:sym typeface="Arial"/>
               </a:rPr>
-              <a:t>bjectives, success criteria, and the campaign verdict</a:t>
+              <a:t>bjectives, success criteria, campaign verdict</a:t>
             </a:r>
             <a:endParaRPr dirty="0"/>
           </a:p>
@@ -23567,7 +23625,7 @@
                 <a:cs typeface="Arial"/>
                 <a:sym typeface="Arial"/>
               </a:rPr>
-              <a:t>   ·   CAC, early customer value, 24-month LTV forecast</a:t>
+              <a:t>   ·   CAC, 24-month LTV forecast</a:t>
             </a:r>
             <a:endParaRPr dirty="0"/>
           </a:p>
@@ -23709,7 +23767,7 @@
               <a:buNone/>
             </a:pPr>
             <a:r>
-              <a:rPr lang="en-US" sz="1400" b="1" i="0">
+              <a:rPr lang="en-US" sz="1400" b="1" i="0" dirty="0">
                 <a:solidFill>
                   <a:srgbClr val="000000"/>
                 </a:solidFill>
@@ -23721,7 +23779,7 @@
               <a:t>Channel Performance</a:t>
             </a:r>
             <a:r>
-              <a:rPr lang="en-US" sz="1000" b="0" i="0">
+              <a:rPr lang="en-US" sz="1000" b="0" i="0" dirty="0">
                 <a:solidFill>
                   <a:srgbClr val="757575"/>
                 </a:solidFill>
@@ -23730,9 +23788,33 @@
                 <a:cs typeface="Arial"/>
                 <a:sym typeface="Arial"/>
               </a:rPr>
-              <a:t>   ·   Spend mix, iROAS, and each channel’s role</a:t>
-            </a:r>
-            <a:endParaRPr/>
+              <a:t>   ·   Spend mix, </a:t>
+            </a:r>
+            <a:r>
+              <a:rPr lang="en-US" sz="1000" b="0" i="0" dirty="0" err="1">
+                <a:solidFill>
+                  <a:srgbClr val="757575"/>
+                </a:solidFill>
+                <a:latin typeface="Arial"/>
+                <a:ea typeface="Arial"/>
+                <a:cs typeface="Arial"/>
+                <a:sym typeface="Arial"/>
+              </a:rPr>
+              <a:t>iROAS</a:t>
+            </a:r>
+            <a:r>
+              <a:rPr lang="en-US" sz="1000" b="0" i="0" dirty="0">
+                <a:solidFill>
+                  <a:srgbClr val="757575"/>
+                </a:solidFill>
+                <a:latin typeface="Arial"/>
+                <a:ea typeface="Arial"/>
+                <a:cs typeface="Arial"/>
+                <a:sym typeface="Arial"/>
+              </a:rPr>
+              <a:t>, each channel’s role</a:t>
+            </a:r>
+            <a:endParaRPr dirty="0"/>
           </a:p>
         </p:txBody>
       </p:sp>
@@ -24150,7 +24232,7 @@
               <a:buNone/>
             </a:pPr>
             <a:r>
-              <a:rPr lang="en-US" sz="1400" b="1" i="0">
+              <a:rPr lang="en-US" sz="1400" b="1" i="0" dirty="0">
                 <a:solidFill>
                   <a:srgbClr val="000000"/>
                 </a:solidFill>
@@ -24162,7 +24244,7 @@
               <a:t>Recommendations</a:t>
             </a:r>
             <a:r>
-              <a:rPr lang="en-US" sz="1000" b="0" i="0">
+              <a:rPr lang="en-US" sz="1000" b="0" i="0" dirty="0">
                 <a:solidFill>
                   <a:srgbClr val="757575"/>
                 </a:solidFill>
@@ -24173,7 +24255,7 @@
               </a:rPr>
               <a:t>   ·   Changes for the next launch</a:t>
             </a:r>
-            <a:endParaRPr/>
+            <a:endParaRPr dirty="0"/>
           </a:p>
         </p:txBody>
       </p:sp>
@@ -24283,7 +24365,7 @@
               <a:buNone/>
             </a:pPr>
             <a:r>
-              <a:rPr lang="en-US" sz="2300" b="0" i="0" u="none" strike="noStrike" cap="none">
+              <a:rPr lang="en-US" sz="2300" b="0" i="0" u="none" strike="noStrike" cap="none" dirty="0">
                 <a:solidFill>
                   <a:srgbClr val="000000"/>
                 </a:solidFill>
@@ -24292,9 +24374,9 @@
                 <a:cs typeface="Georgia"/>
                 <a:sym typeface="Georgia"/>
               </a:rPr>
-              <a:t>Vestal Pro: a new ultra-running franchise, launched with a 20-day GTM campaign</a:t>
-            </a:r>
-            <a:endParaRPr sz="2300" b="0" i="0" u="none" strike="noStrike" cap="none">
+              <a:t>Vestal Pro: a new ultra-running line, launched with a 20-day GTM campaign</a:t>
+            </a:r>
+            <a:endParaRPr sz="2300" b="0" i="0" u="none" strike="noStrike" cap="none" dirty="0">
               <a:solidFill>
                 <a:srgbClr val="000000"/>
               </a:solidFill>
@@ -24413,7 +24495,7 @@
           <p:nvPr/>
         </p:nvPicPr>
         <p:blipFill rotWithShape="1">
-          <a:blip r:embed="rId4">
+          <a:blip r:embed="rId3">
             <a:alphaModFix/>
           </a:blip>
           <a:srcRect/>
@@ -24514,18 +24596,14 @@
               <a:buNone/>
             </a:pPr>
             <a:r>
-              <a:rPr lang="en-US" sz="1100" b="0" i="0">
+              <a:rPr lang="en-US" sz="1100" dirty="0">
                 <a:solidFill>
                   <a:srgbClr val="333333"/>
                 </a:solidFill>
-                <a:latin typeface="Arial"/>
-                <a:ea typeface="Arial"/>
-                <a:cs typeface="Arial"/>
-                <a:sym typeface="Arial"/>
-              </a:rPr>
-              <a:t>High-cushion ultra-distance trail shoe · full-price launch · June 2026 · Salomon NA eCommerce</a:t>
-            </a:r>
-            <a:endParaRPr/>
+              </a:rPr>
+              <a:t>June 2026 launch of a high-cushion ultra-running trail in Salomon’s North American market. </a:t>
+            </a:r>
+            <a:endParaRPr dirty="0"/>
           </a:p>
         </p:txBody>
       </p:sp>
@@ -24610,7 +24688,7 @@
               <a:buNone/>
             </a:pPr>
             <a:r>
-              <a:rPr lang="en-US" sz="1100" b="0" i="0">
+              <a:rPr lang="en-US" sz="1100" b="0" i="0" dirty="0">
                 <a:solidFill>
                   <a:srgbClr val="333333"/>
                 </a:solidFill>
@@ -24619,9 +24697,9 @@
                 <a:cs typeface="Arial"/>
                 <a:sym typeface="Arial"/>
               </a:rPr>
-              <a:t>GA4 sessions, source, views &amp; conversion · order-level sales · marketing spend by channel · ATS inventory · GSC brand queries · Mar 1 – Jul 20, 2026</a:t>
-            </a:r>
-            <a:endParaRPr/>
+              <a:t>GA4 sessions, source, views &amp; conversion; order-level sales; marketing spend by channel; ATS inventory; GSC brand queries</a:t>
+            </a:r>
+            <a:endParaRPr dirty="0"/>
           </a:p>
         </p:txBody>
       </p:sp>
@@ -25966,11 +26044,6 @@
   <p:clrMapOvr>
     <a:masterClrMapping/>
   </p:clrMapOvr>
-  <p:extLst>
-    <p:ext uri="{6950BFC3-D8DA-4A85-94F7-54DA5524770B}">
-      <p188:commentRel xmlns:p188="http://schemas.microsoft.com/office/powerpoint/2018/8/main" r:id="rId3"/>
-    </p:ext>
-  </p:extLst>
 </p:sld>
 </file>
 
@@ -26081,7 +26154,7 @@
               <a:buNone/>
             </a:pPr>
             <a:r>
-              <a:rPr lang="en-US" sz="2300" b="0" i="0" u="none" strike="noStrike" cap="none">
+              <a:rPr lang="en-US" sz="2300" b="0" i="0" u="none" strike="noStrike" cap="none" dirty="0">
                 <a:solidFill>
                   <a:srgbClr val="000000"/>
                 </a:solidFill>
@@ -26090,9 +26163,9 @@
                 <a:cs typeface="Georgia"/>
                 <a:sym typeface="Georgia"/>
               </a:rPr>
-              <a:t>Successful Launch; Monitor for continued cannibalization and shifting sales mix</a:t>
-            </a:r>
-            <a:endParaRPr sz="2300" b="0" i="0" u="none" strike="noStrike" cap="none">
+              <a:t>Launch was successful; Monitor for continued cannibalization and shifting sales mix</a:t>
+            </a:r>
+            <a:endParaRPr sz="2300" b="0" i="0" u="none" strike="noStrike" cap="none" dirty="0">
               <a:solidFill>
                 <a:srgbClr val="000000"/>
               </a:solidFill>
@@ -27245,7 +27318,7 @@
         <p:spPr>
           <a:xfrm>
             <a:off x="868680" y="4681728"/>
-            <a:ext cx="10470000" cy="1113600"/>
+            <a:ext cx="10470000" cy="1142236"/>
           </a:xfrm>
           <a:prstGeom prst="rect">
             <a:avLst/>
@@ -27274,7 +27347,7 @@
               <a:buNone/>
             </a:pPr>
             <a:r>
-              <a:rPr lang="en-US" sz="1400" b="1" i="0" u="none" strike="noStrike" cap="none">
+              <a:rPr lang="en-US" sz="1400" b="1" i="0" u="none" strike="noStrike" cap="none" dirty="0">
                 <a:solidFill>
                   <a:srgbClr val="FFFFFF"/>
                 </a:solidFill>
@@ -27283,9 +27356,9 @@
                 <a:cs typeface="Arial"/>
                 <a:sym typeface="Arial"/>
               </a:rPr>
-              <a:t>VERDICT — a commercial success limited by availability.</a:t>
-            </a:r>
-            <a:endParaRPr/>
+              <a:t>VERDICT: a commercial success limited by availability.</a:t>
+            </a:r>
+            <a:endParaRPr dirty="0"/>
           </a:p>
           <a:p>
             <a:pPr marL="0" marR="0" lvl="0" indent="0" algn="l" rtl="0">
@@ -27301,7 +27374,7 @@
               <a:buNone/>
             </a:pPr>
             <a:r>
-              <a:rPr lang="en-US" sz="1250" b="0" i="0" u="none" strike="noStrike" cap="none">
+              <a:rPr lang="en-US" sz="1250" b="0" i="0" u="none" strike="noStrike" cap="none" dirty="0">
                 <a:solidFill>
                   <a:srgbClr val="FFFFFF"/>
                 </a:solidFill>
@@ -27313,7 +27386,7 @@
               <a:t>$99.8K </a:t>
             </a:r>
             <a:r>
-              <a:rPr lang="en-US" sz="1250" b="0" i="0" u="sng" strike="noStrike" cap="none">
+              <a:rPr lang="en-US" sz="1250" b="0" i="0" u="sng" strike="noStrike" cap="none" dirty="0">
                 <a:solidFill>
                   <a:srgbClr val="FFFFFF"/>
                 </a:solidFill>
@@ -27325,7 +27398,7 @@
               <a:t>direct revenue</a:t>
             </a:r>
             <a:r>
-              <a:rPr lang="en-US" sz="1250" b="0" i="0" u="none" strike="noStrike" cap="none">
+              <a:rPr lang="en-US" sz="1250" b="0" i="0" u="none" strike="noStrike" cap="none" dirty="0">
                 <a:solidFill>
                   <a:srgbClr val="FFFFFF"/>
                 </a:solidFill>
@@ -27337,7 +27410,7 @@
               <a:t> · $77.5K </a:t>
             </a:r>
             <a:r>
-              <a:rPr lang="en-US" sz="1250" b="0" i="0" u="sng" strike="noStrike" cap="none">
+              <a:rPr lang="en-US" sz="1250" b="0" i="0" u="sng" strike="noStrike" cap="none" dirty="0">
                 <a:solidFill>
                   <a:srgbClr val="FFFFFF"/>
                 </a:solidFill>
@@ -27349,7 +27422,7 @@
               <a:t>net incremental revenue</a:t>
             </a:r>
             <a:r>
-              <a:rPr lang="en-US" sz="1250" b="0" i="0" u="none" strike="noStrike" cap="none">
+              <a:rPr lang="en-US" sz="1250" b="0" i="0" u="none" strike="noStrike" cap="none" dirty="0">
                 <a:solidFill>
                   <a:srgbClr val="FFFFFF"/>
                 </a:solidFill>
@@ -27360,7 +27433,7 @@
               </a:rPr>
               <a:t> (+33% vs baseline) · </a:t>
             </a:r>
-            <a:endParaRPr sz="1250" b="0" i="0" u="none" strike="noStrike" cap="none">
+            <a:endParaRPr sz="1250" b="0" i="0" u="none" strike="noStrike" cap="none" dirty="0">
               <a:solidFill>
                 <a:srgbClr val="FFFFFF"/>
               </a:solidFill>
@@ -27384,7 +27457,7 @@
               <a:buNone/>
             </a:pPr>
             <a:r>
-              <a:rPr lang="en-US" sz="1250" b="0" i="0" u="none" strike="noStrike" cap="none">
+              <a:rPr lang="en-US" sz="1250" b="0" i="0" u="none" strike="noStrike" cap="none" dirty="0">
                 <a:solidFill>
                   <a:srgbClr val="FFFFFF"/>
                 </a:solidFill>
@@ -27396,7 +27469,7 @@
               <a:t>$34.5K after incremental media · </a:t>
             </a:r>
             <a:r>
-              <a:rPr lang="en-US" sz="1250" b="0" i="0" u="sng" strike="noStrike" cap="none">
+              <a:rPr lang="en-US" sz="1250" b="0" i="0" u="sng" strike="noStrike" cap="none" dirty="0">
                 <a:solidFill>
                   <a:srgbClr val="FFFFFF"/>
                 </a:solidFill>
@@ -27408,7 +27481,7 @@
               <a:t>$3.5K CM3</a:t>
             </a:r>
             <a:r>
-              <a:rPr lang="en-US" sz="1250" b="0" i="0" u="none" strike="noStrike" cap="none">
+              <a:rPr lang="en-US" sz="1250" b="0" i="0" u="none" strike="noStrike" cap="none" dirty="0">
                 <a:solidFill>
                   <a:srgbClr val="FFFFFF"/>
                 </a:solidFill>
@@ -27419,7 +27492,7 @@
               </a:rPr>
               <a:t>. </a:t>
             </a:r>
-            <a:endParaRPr/>
+            <a:endParaRPr dirty="0"/>
           </a:p>
           <a:p>
             <a:pPr marL="0" marR="0" lvl="0" indent="0" algn="l" rtl="0">
@@ -27435,7 +27508,7 @@
               <a:buNone/>
             </a:pPr>
             <a:r>
-              <a:rPr lang="en-US" sz="1250" b="0" i="0" u="sng" strike="noStrike" cap="none">
+              <a:rPr lang="en-US" sz="1250" b="0" i="0" u="sng" strike="noStrike" cap="none" dirty="0">
                 <a:solidFill>
                   <a:srgbClr val="FFFFFF"/>
                 </a:solidFill>
@@ -27447,7 +27520,7 @@
               <a:t>Cannibalization and core-size availability</a:t>
             </a:r>
             <a:r>
-              <a:rPr lang="en-US" sz="1250" b="0" i="0" u="none" strike="noStrike" cap="none">
+              <a:rPr lang="en-US" sz="1250" b="0" i="0" u="none" strike="noStrike" cap="none" dirty="0">
                 <a:solidFill>
                   <a:srgbClr val="FFFFFF"/>
                 </a:solidFill>
@@ -27458,7 +27531,7 @@
               </a:rPr>
               <a:t> capped the upside.</a:t>
             </a:r>
-            <a:endParaRPr sz="1250" b="0" i="0" u="none" strike="noStrike" cap="none">
+            <a:endParaRPr sz="1250" b="0" i="0" u="none" strike="noStrike" cap="none" dirty="0">
               <a:solidFill>
                 <a:srgbClr val="FFFFFF"/>
               </a:solidFill>
@@ -27838,6 +27911,33 @@
           <a:chExt cx="0" cy="0"/>
         </a:xfrm>
       </p:grpSpPr>
+      <p:pic>
+        <p:nvPicPr>
+          <p:cNvPr id="175" name="Google Shape;175;p4" descr="The diagram illustrates a comparison of actual footwear revenue against a modeled baseline without campaigns, showing fluctuations over a period from April to July 2026.&#10;&#10;AI-generated content may be incorrect."/>
+          <p:cNvPicPr preferRelativeResize="0"/>
+          <p:nvPr/>
+        </p:nvPicPr>
+        <p:blipFill rotWithShape="1">
+          <a:blip r:embed="rId3">
+            <a:alphaModFix/>
+          </a:blip>
+          <a:srcRect/>
+          <a:stretch/>
+        </p:blipFill>
+        <p:spPr>
+          <a:xfrm>
+            <a:off x="502919" y="1371973"/>
+            <a:ext cx="8178093" cy="4639209"/>
+          </a:xfrm>
+          <a:prstGeom prst="rect">
+            <a:avLst/>
+          </a:prstGeom>
+          <a:noFill/>
+          <a:ln>
+            <a:noFill/>
+          </a:ln>
+        </p:spPr>
+      </p:pic>
       <p:sp>
         <p:nvSpPr>
           <p:cNvPr id="3" name="AgendaCard">
@@ -28098,33 +28198,6 @@
           <p:nvPr/>
         </p:nvPicPr>
         <p:blipFill rotWithShape="1">
-          <a:blip r:embed="rId3">
-            <a:alphaModFix/>
-          </a:blip>
-          <a:srcRect/>
-          <a:stretch/>
-        </p:blipFill>
-        <p:spPr>
-          <a:xfrm>
-            <a:off x="10698480" y="292608"/>
-            <a:ext cx="960120" cy="110013"/>
-          </a:xfrm>
-          <a:prstGeom prst="rect">
-            <a:avLst/>
-          </a:prstGeom>
-          <a:noFill/>
-          <a:ln>
-            <a:noFill/>
-          </a:ln>
-        </p:spPr>
-      </p:pic>
-      <p:pic>
-        <p:nvPicPr>
-          <p:cNvPr id="175" name="Google Shape;175;p4" descr="The diagram illustrates a comparison of actual footwear revenue against a modeled baseline without campaigns, showing fluctuations over a period from April to July 2026.&#10;&#10;AI-generated content may be incorrect."/>
-          <p:cNvPicPr preferRelativeResize="0"/>
-          <p:nvPr/>
-        </p:nvPicPr>
-        <p:blipFill rotWithShape="1">
           <a:blip r:embed="rId4">
             <a:alphaModFix/>
           </a:blip>
@@ -28133,8 +28206,8 @@
         </p:blipFill>
         <p:spPr>
           <a:xfrm>
-            <a:off x="502919" y="1371973"/>
-            <a:ext cx="8178093" cy="4639209"/>
+            <a:off x="10698480" y="292608"/>
+            <a:ext cx="960120" cy="110013"/>
           </a:xfrm>
           <a:prstGeom prst="rect">
             <a:avLst/>
@@ -28400,7 +28473,7 @@
         <p:spPr>
           <a:xfrm>
             <a:off x="8745156" y="1989167"/>
-            <a:ext cx="3108960" cy="2717219"/>
+            <a:ext cx="3108960" cy="2818720"/>
           </a:xfrm>
           <a:prstGeom prst="rect">
             <a:avLst/>
@@ -28666,6 +28739,14 @@
               <a:buNone/>
             </a:pPr>
             <a:r>
+              <a:rPr lang="en-US" sz="1050" dirty="0">
+                <a:solidFill>
+                  <a:srgbClr val="333333"/>
+                </a:solidFill>
+              </a:rPr>
+              <a:t>E</a:t>
+            </a:r>
+            <a:r>
               <a:rPr lang="en-US" sz="1050" b="0" i="0" dirty="0">
                 <a:solidFill>
                   <a:srgbClr val="333333"/>
@@ -28675,31 +28756,7 @@
                 <a:cs typeface="Arial"/>
                 <a:sym typeface="Arial"/>
               </a:rPr>
-              <a:t>95% CI +32% to +</a:t>
-            </a:r>
-            <a:r>
-              <a:rPr lang="en-US" sz="1050" dirty="0">
-                <a:solidFill>
-                  <a:srgbClr val="333333"/>
-                </a:solidFill>
-                <a:latin typeface="Arial"/>
-                <a:ea typeface="Arial"/>
-                <a:cs typeface="Arial"/>
-                <a:sym typeface="Arial"/>
-              </a:rPr>
-              <a:t>40</a:t>
-            </a:r>
-            <a:r>
-              <a:rPr lang="en-US" sz="1050" b="0" i="0" dirty="0">
-                <a:solidFill>
-                  <a:srgbClr val="333333"/>
-                </a:solidFill>
-                <a:latin typeface="Arial"/>
-                <a:ea typeface="Arial"/>
-                <a:cs typeface="Arial"/>
-                <a:sym typeface="Arial"/>
-              </a:rPr>
-              <a:t>% · every campaign week ran above baseline · peak gap +$</a:t>
+              <a:t>very campaign week ran above baseline; Peak gap +$</a:t>
             </a:r>
             <a:r>
               <a:rPr lang="en-US" sz="1050" dirty="0">
@@ -31006,7 +31063,7 @@
               <a:buNone/>
             </a:pPr>
             <a:r>
-              <a:rPr lang="en-US" sz="2300" b="0" i="0">
+              <a:rPr lang="en-US" sz="2300" b="0" i="0" dirty="0">
                 <a:solidFill>
                   <a:srgbClr val="000000"/>
                 </a:solidFill>
@@ -31018,7 +31075,7 @@
               <a:t>19–32% of Vestal Pro units shifted from existing shoes; exceeding </a:t>
             </a:r>
             <a:r>
-              <a:rPr lang="en-US" sz="2300">
+              <a:rPr lang="en-US" sz="2300" dirty="0">
                 <a:solidFill>
                   <a:srgbClr val="000000"/>
                 </a:solidFill>
@@ -31029,7 +31086,7 @@
               </a:rPr>
               <a:t>10% threshold.</a:t>
             </a:r>
-            <a:endParaRPr sz="2300" b="0" i="0">
+            <a:endParaRPr sz="2300" b="0" i="0" dirty="0">
               <a:solidFill>
                 <a:srgbClr val="000000"/>
               </a:solidFill>
@@ -32661,7 +32718,7 @@
               <a:buNone/>
             </a:pPr>
             <a:r>
-              <a:rPr lang="en-US" sz="2300" b="0" i="0">
+              <a:rPr lang="en-US" sz="2300" b="0" i="0" dirty="0">
                 <a:solidFill>
                   <a:srgbClr val="000000"/>
                 </a:solidFill>
@@ -32673,7 +32730,7 @@
               <a:t>40% of Vestal Pro buyers were new to Salomon</a:t>
             </a:r>
             <a:r>
-              <a:rPr lang="en-US" sz="2300">
+              <a:rPr lang="en-US" sz="2300" dirty="0">
                 <a:solidFill>
                   <a:srgbClr val="000000"/>
                 </a:solidFill>
@@ -32685,7 +32742,7 @@
               <a:t>. A</a:t>
             </a:r>
             <a:r>
-              <a:rPr lang="en-US" sz="2300" b="0" i="0">
+              <a:rPr lang="en-US" sz="2300" b="0" i="0" dirty="0">
                 <a:solidFill>
                   <a:srgbClr val="000000"/>
                 </a:solidFill>
@@ -32694,9 +32751,30 @@
                 <a:cs typeface="Georgia"/>
                 <a:sym typeface="Georgia"/>
               </a:rPr>
-              <a:t>cquired at half early value.</a:t>
-            </a:r>
-            <a:endParaRPr/>
+              <a:t>cquired at </a:t>
+            </a:r>
+            <a:r>
+              <a:rPr lang="en-US" sz="2300" dirty="0">
+                <a:latin typeface="Georgia"/>
+                <a:ea typeface="Georgia"/>
+                <a:cs typeface="Georgia"/>
+                <a:sym typeface="Georgia"/>
+              </a:rPr>
+              <a:t>about </a:t>
+            </a:r>
+            <a:r>
+              <a:rPr lang="en-US" sz="2300" b="0" i="0" dirty="0">
+                <a:solidFill>
+                  <a:srgbClr val="000000"/>
+                </a:solidFill>
+                <a:latin typeface="Georgia"/>
+                <a:ea typeface="Georgia"/>
+                <a:cs typeface="Georgia"/>
+                <a:sym typeface="Georgia"/>
+              </a:rPr>
+              <a:t>half early value.</a:t>
+            </a:r>
+            <a:endParaRPr dirty="0"/>
           </a:p>
         </p:txBody>
       </p:sp>

</xml_diff>